<commit_message>
Roster cleanup: remove IICT technical staff and wrong matches (D-20)
</commit_message>
<xml_diff>
--- a/dpcn_a2/final_submission/24_CSIR.pptx
+++ b/dpcn_a2/final_submission/24_CSIR.pptx
@@ -1259,16 +1259,16 @@
                 <c:formatCode>General</c:formatCode>
                 <c:ptCount val="8"/>
                 <c:pt idx="0">
-                  <c:v>82</c:v>
+                  <c:v>55</c:v>
                 </c:pt>
                 <c:pt idx="1">
-                  <c:v>41</c:v>
+                  <c:v>30</c:v>
                 </c:pt>
                 <c:pt idx="2">
                   <c:v>19</c:v>
                 </c:pt>
                 <c:pt idx="3">
-                  <c:v>17</c:v>
+                  <c:v>15</c:v>
                 </c:pt>
                 <c:pt idx="4">
                   <c:v>5</c:v>
@@ -1356,7 +1356,7 @@
                   <c:v>33</c:v>
                 </c:pt>
                 <c:pt idx="3">
-                  <c:v>17</c:v>
+                  <c:v>16</c:v>
                 </c:pt>
                 <c:pt idx="4">
                   <c:v>8</c:v>
@@ -2232,7 +2232,7 @@
             <c:idx val="0"/>
             <c:spPr>
               <a:solidFill>
-                <a:srgbClr val="2E7D32"/>
+                <a:srgbClr val="D95F02"/>
               </a:solidFill>
             </c:spPr>
           </c:dPt>
@@ -2240,7 +2240,7 @@
             <c:idx val="1"/>
             <c:spPr>
               <a:solidFill>
-                <a:srgbClr val="2B5C8F"/>
+                <a:srgbClr val="2E7D32"/>
               </a:solidFill>
             </c:spPr>
           </c:dPt>
@@ -2248,7 +2248,7 @@
             <c:idx val="2"/>
             <c:spPr>
               <a:solidFill>
-                <a:srgbClr val="D95F02"/>
+                <a:srgbClr val="2B5C8F"/>
               </a:solidFill>
             </c:spPr>
           </c:dPt>
@@ -2264,7 +2264,7 @@
             <c:idx val="4"/>
             <c:spPr>
               <a:solidFill>
-                <a:srgbClr val="D95F02"/>
+                <a:srgbClr val="2E7D32"/>
               </a:solidFill>
             </c:spPr>
           </c:dPt>
@@ -2272,7 +2272,7 @@
             <c:idx val="5"/>
             <c:spPr>
               <a:solidFill>
-                <a:srgbClr val="2B5C8F"/>
+                <a:srgbClr val="D95F02"/>
               </a:solidFill>
             </c:spPr>
           </c:dPt>
@@ -2280,7 +2280,7 @@
             <c:idx val="6"/>
             <c:spPr>
               <a:solidFill>
-                <a:srgbClr val="2E7D32"/>
+                <a:srgbClr val="2B5C8F"/>
               </a:solidFill>
             </c:spPr>
           </c:dPt>
@@ -2331,28 +2331,28 @@
                 <c:formatCode>General</c:formatCode>
                 <c:ptCount val="8"/>
                 <c:pt idx="0">
-                  <c:v>575</c:v>
+                  <c:v>611</c:v>
                 </c:pt>
                 <c:pt idx="1">
-                  <c:v>513</c:v>
+                  <c:v>555</c:v>
                 </c:pt>
                 <c:pt idx="2">
-                  <c:v>483</c:v>
+                  <c:v>525</c:v>
                 </c:pt>
                 <c:pt idx="3">
-                  <c:v>467</c:v>
+                  <c:v>514</c:v>
                 </c:pt>
                 <c:pt idx="4">
-                  <c:v>459</c:v>
+                  <c:v>481</c:v>
                 </c:pt>
                 <c:pt idx="5">
-                  <c:v>450</c:v>
+                  <c:v>424</c:v>
                 </c:pt>
                 <c:pt idx="6">
-                  <c:v>449</c:v>
+                  <c:v>370</c:v>
                 </c:pt>
                 <c:pt idx="7">
-                  <c:v>375</c:v>
+                  <c:v>357</c:v>
                 </c:pt>
               </c:numCache>
             </c:numRef>
@@ -7041,7 +7041,7 @@
                           </a:solidFill>
                           <a:latin typeface="Calibri"/>
                         </a:rPr>
-                        <a:t>287</a:t>
+                        <a:t>168</a:t>
                       </a:r>
                     </a:p>
                   </a:txBody>
@@ -7064,7 +7064,7 @@
                           </a:solidFill>
                           <a:latin typeface="Calibri"/>
                         </a:rPr>
-                        <a:t>169</a:t>
+                        <a:t>129</a:t>
                       </a:r>
                     </a:p>
                   </a:txBody>
@@ -7250,7 +7250,7 @@
                           </a:solidFill>
                           <a:latin typeface="Calibri"/>
                         </a:rPr>
-                        <a:t>167</a:t>
+                        <a:t>166</a:t>
                       </a:r>
                     </a:p>
                   </a:txBody>
@@ -7273,7 +7273,7 @@
                           </a:solidFill>
                           <a:latin typeface="Calibri"/>
                         </a:rPr>
-                        <a:t>152</a:t>
+                        <a:t>151</a:t>
                       </a:r>
                     </a:p>
                   </a:txBody>
@@ -7668,7 +7668,7 @@
                           </a:solidFill>
                           <a:latin typeface="Calibri"/>
                         </a:rPr>
-                        <a:t>505</a:t>
+                        <a:t>385</a:t>
                       </a:r>
                     </a:p>
                   </a:txBody>
@@ -7691,7 +7691,7 @@
                           </a:solidFill>
                           <a:latin typeface="Calibri"/>
                         </a:rPr>
-                        <a:t>347</a:t>
+                        <a:t>306</a:t>
                       </a:r>
                     </a:p>
                   </a:txBody>
@@ -8341,7 +8341,7 @@
                           </a:solidFill>
                           <a:latin typeface="Calibri"/>
                         </a:rPr>
-                        <a:t>The top 1% most-connected researchers show no rich-club effect and are less interconnected than chance (ρ_norm = 0.74). 41 of 78 are CSIR faculty.</a:t>
+                        <a:t>The top 1% most-connected researchers show no rich-club effect and are less interconnected than chance (ρ_norm = 0.75). 39 of 78 are CSIR faculty.</a:t>
                       </a:r>
                     </a:p>
                   </a:txBody>
@@ -8412,7 +8412,7 @@
                           </a:solidFill>
                           <a:latin typeface="Calibri"/>
                         </a:rPr>
-                        <a:t>Removing the top 872 bridge researchers (11.6% of the network) halves the cluster; random removal needs 3,279. Removing 608 of them separates the three labs' faculty into different components.</a:t>
+                        <a:t>Removing the top 841 bridge researchers (11.2% of the network) halves the cluster; random removal needs 3,282. Removing 644 of them separates the three labs' faculty into different components.</a:t>
                       </a:r>
                     </a:p>
                   </a:txBody>
@@ -8483,7 +8483,7 @@
                           </a:solidFill>
                           <a:latin typeface="Calibri"/>
                         </a:rPr>
-                        <a:t>√N = 19 scientists produce 36.2% of the cluster's papers (Price's law predicts 50%). The top 10% produce 50.3%; Gini = 0.63 (papers), 0.75 (citations).</a:t>
+                        <a:t>√N = 18 scientists produce 35.8% of the cluster's papers (Price's law predicts 50%). The top 10% produce 48.2%; Gini = 0.61 (papers), 0.74 (citations).</a:t>
                       </a:r>
                     </a:p>
                   </a:txBody>
@@ -8838,7 +8838,7 @@
                           </a:solidFill>
                           <a:latin typeface="Calibri"/>
                         </a:rPr>
-                        <a:t>15.7% of classifiable CSIR scientists are returnees (NCL 18.3% (n=142), IICT 13.5% (n=133), CECRI 11.1% (n=18)); their abroad spell was most often in the US (25 of 46). Their papers' citations do not differ significantly from home-grown peers of similar career age (+2%, 95% CI -24% to +37%); 20.3% of returnees' papers vs 16.8% of home-grown scientists' papers have a foreign co-author.</a:t>
+                        <a:t>17.0% of classifiable CSIR scientists are returnees (NCL 17.7% (n=141), IICT 17.0% (n=106), CECRI 11.1% (n=18)); their abroad spell was most often in the US (25 of 45). Their papers' citations do not differ significantly from home-grown peers of similar career age (+8%, 95% CI -20% to +46%); 20.6% of returnees' papers vs 16.9% of home-grown scientists' papers have a foreign co-author.</a:t>
                       </a:r>
                     </a:p>
                   </a:txBody>
@@ -8909,7 +8909,7 @@
                           </a:solidFill>
                           <a:latin typeface="Calibri"/>
                         </a:rPr>
-                        <a:t>In CECRI, 46.3% of recent papers (48.6% of their citations) have only roster authors likely to retire within ~5 years (IICT 20.2%, NCL 11.5%). Highest exposure: Electrochemical Process Engineering, CECRI (74.6% of 193 papers).</a:t>
+                        <a:t>In CECRI, 46.3% of recent papers (48.6% of their citations) have only roster authors likely to retire within ~5 years (IICT 20.8%, NCL 11.5%). Highest exposure: Electrochemical Process Engineering, CECRI (74.6% of 193 papers).</a:t>
                       </a:r>
                     </a:p>
                   </a:txBody>
@@ -10345,7 +10345,7 @@
                 </a:solidFill>
                 <a:latin typeface="Calibri"/>
               </a:rPr>
-              <a:t>Median h-index of the 347 roster scientists with papers is 6; CECRI 2.5, NCL 8, IICT 5</a:t>
+              <a:t>Median h-index of the 306 roster scientists with papers is 7; CECRI 2.5, NCL 8, IICT 6</a:t>
             </a:r>
           </a:p>
         </p:txBody>
@@ -10592,7 +10592,7 @@
                           </a:solidFill>
                           <a:latin typeface="Calibri"/>
                         </a:rPr>
-                        <a:t>169</a:t>
+                        <a:t>129</a:t>
                       </a:r>
                     </a:p>
                   </a:txBody>
@@ -10615,7 +10615,7 @@
                           </a:solidFill>
                           <a:latin typeface="Calibri"/>
                         </a:rPr>
-                        <a:t>5</a:t>
+                        <a:t>6</a:t>
                       </a:r>
                     </a:p>
                   </a:txBody>
@@ -10638,7 +10638,7 @@
                           </a:solidFill>
                           <a:latin typeface="Calibri"/>
                         </a:rPr>
-                        <a:t>7.0</a:t>
+                        <a:t>8.1</a:t>
                       </a:r>
                     </a:p>
                   </a:txBody>
@@ -10661,7 +10661,7 @@
                           </a:solidFill>
                           <a:latin typeface="Calibri"/>
                         </a:rPr>
-                        <a:t>10</a:t>
+                        <a:t>12</a:t>
                       </a:r>
                     </a:p>
                   </a:txBody>
@@ -10732,7 +10732,7 @@
                           </a:solidFill>
                           <a:latin typeface="Calibri"/>
                         </a:rPr>
-                        <a:t>152</a:t>
+                        <a:t>151</a:t>
                       </a:r>
                     </a:p>
                   </a:txBody>
@@ -11012,7 +11012,7 @@
                           </a:solidFill>
                           <a:latin typeface="Calibri"/>
                         </a:rPr>
-                        <a:t>347</a:t>
+                        <a:t>306</a:t>
                       </a:r>
                     </a:p>
                   </a:txBody>
@@ -11035,7 +11035,7 @@
                           </a:solidFill>
                           <a:latin typeface="Calibri"/>
                         </a:rPr>
-                        <a:t>6</a:t>
+                        <a:t>7</a:t>
                       </a:r>
                     </a:p>
                   </a:txBody>
@@ -11058,7 +11058,7 @@
                           </a:solidFill>
                           <a:latin typeface="Calibri"/>
                         </a:rPr>
-                        <a:t>8.6</a:t>
+                        <a:t>9.3</a:t>
                       </a:r>
                     </a:p>
                   </a:txBody>
@@ -11081,7 +11081,7 @@
                           </a:solidFill>
                           <a:latin typeface="Calibri"/>
                         </a:rPr>
-                        <a:t>13</a:t>
+                        <a:t>14</a:t>
                       </a:r>
                     </a:p>
                   </a:txBody>
@@ -17127,7 +17127,7 @@
                           </a:solidFill>
                           <a:latin typeface="Calibri"/>
                         </a:rPr>
-                        <a:t>Applied Biology</a:t>
+                        <a:t>Polymers &amp; Functional Materials</a:t>
                       </a:r>
                     </a:p>
                   </a:txBody>
@@ -17173,7 +17173,7 @@
                           </a:solidFill>
                           <a:latin typeface="Calibri"/>
                         </a:rPr>
-                        <a:t>21</a:t>
+                        <a:t>15</a:t>
                       </a:r>
                     </a:p>
                   </a:txBody>
@@ -17196,7 +17196,7 @@
                           </a:solidFill>
                           <a:latin typeface="Calibri"/>
                         </a:rPr>
-                        <a:t>509</a:t>
+                        <a:t>498</a:t>
                       </a:r>
                     </a:p>
                   </a:txBody>
@@ -17219,7 +17219,7 @@
                           </a:solidFill>
                           <a:latin typeface="Calibri"/>
                         </a:rPr>
-                        <a:t>56%</a:t>
+                        <a:t>68%</a:t>
                       </a:r>
                     </a:p>
                   </a:txBody>
@@ -17244,7 +17244,7 @@
                           </a:solidFill>
                           <a:latin typeface="Calibri"/>
                         </a:rPr>
-                        <a:t>Polymers &amp; Functional Materials</a:t>
+                        <a:t>Applied Biology</a:t>
                       </a:r>
                     </a:p>
                   </a:txBody>
@@ -17290,7 +17290,7 @@
                           </a:solidFill>
                           <a:latin typeface="Calibri"/>
                         </a:rPr>
-                        <a:t>19</a:t>
+                        <a:t>16</a:t>
                       </a:r>
                     </a:p>
                   </a:txBody>
@@ -17313,7 +17313,7 @@
                           </a:solidFill>
                           <a:latin typeface="Calibri"/>
                         </a:rPr>
-                        <a:t>504</a:t>
+                        <a:t>477</a:t>
                       </a:r>
                     </a:p>
                   </a:txBody>
@@ -17336,7 +17336,7 @@
                           </a:solidFill>
                           <a:latin typeface="Calibri"/>
                         </a:rPr>
-                        <a:t>68%</a:t>
+                        <a:t>56%</a:t>
                       </a:r>
                     </a:p>
                   </a:txBody>
@@ -20690,7 +20690,7 @@
                 </a:solidFill>
                 <a:latin typeface="Calibri"/>
               </a:rPr>
-              <a:t>7,864 authors, 35,423 co-author pairs; Louvain finds 130 communities (modularity 0.81), almost all within a single lab</a:t>
+              <a:t>7,865 authors, 35,426 co-author pairs; Louvain finds 131 communities (modularity 0.82), almost all within a single lab</a:t>
             </a:r>
           </a:p>
         </p:txBody>
@@ -20814,7 +20814,7 @@
                 </a:solidFill>
                 <a:latin typeface="Calibri"/>
               </a:rPr>
-              <a:t>7,864</a:t>
+              <a:t>7,865</a:t>
             </a:r>
           </a:p>
           <a:p>
@@ -21016,7 +21016,7 @@
                 </a:solidFill>
                 <a:latin typeface="Calibri"/>
               </a:rPr>
-              <a:t>130</a:t>
+              <a:t>131</a:t>
             </a:r>
           </a:p>
           <a:p>
@@ -21032,7 +21032,7 @@
                 </a:solidFill>
                 <a:latin typeface="Calibri"/>
               </a:rPr>
-              <a:t>Louvain communities (31 with ≥10 authors)</a:t>
+              <a:t>Louvain communities (32 with ≥10 authors)</a:t>
             </a:r>
           </a:p>
         </p:txBody>
@@ -21434,7 +21434,7 @@
                           </a:solidFill>
                           <a:latin typeface="Calibri"/>
                         </a:rPr>
-                        <a:t>0.096</a:t>
+                        <a:t>0.098</a:t>
                       </a:r>
                     </a:p>
                   </a:txBody>
@@ -21480,7 +21480,7 @@
                           </a:solidFill>
                           <a:latin typeface="Calibri"/>
                         </a:rPr>
-                        <a:t>6</a:t>
+                        <a:t>3</a:t>
                       </a:r>
                     </a:p>
                   </a:txBody>
@@ -21597,7 +21597,7 @@
                           </a:solidFill>
                           <a:latin typeface="Calibri"/>
                         </a:rPr>
-                        <a:t>0.090</a:t>
+                        <a:t>0.097</a:t>
                       </a:r>
                     </a:p>
                   </a:txBody>
@@ -21643,7 +21643,7 @@
                           </a:solidFill>
                           <a:latin typeface="Calibri"/>
                         </a:rPr>
-                        <a:t>18</a:t>
+                        <a:t>16</a:t>
                       </a:r>
                     </a:p>
                   </a:txBody>
@@ -21760,7 +21760,7 @@
                           </a:solidFill>
                           <a:latin typeface="Calibri"/>
                         </a:rPr>
-                        <a:t>0.061</a:t>
+                        <a:t>0.059</a:t>
                       </a:r>
                     </a:p>
                   </a:txBody>
@@ -21806,7 +21806,7 @@
                           </a:solidFill>
                           <a:latin typeface="Calibri"/>
                         </a:rPr>
-                        <a:t>4</a:t>
+                        <a:t>5</a:t>
                       </a:r>
                     </a:p>
                   </a:txBody>
@@ -21923,7 +21923,7 @@
                           </a:solidFill>
                           <a:latin typeface="Calibri"/>
                         </a:rPr>
-                        <a:t>0.055</a:t>
+                        <a:t>0.056</a:t>
                       </a:r>
                     </a:p>
                   </a:txBody>
@@ -21969,7 +21969,7 @@
                           </a:solidFill>
                           <a:latin typeface="Calibri"/>
                         </a:rPr>
-                        <a:t>8</a:t>
+                        <a:t>9</a:t>
                       </a:r>
                     </a:p>
                   </a:txBody>
@@ -22132,7 +22132,7 @@
                           </a:solidFill>
                           <a:latin typeface="Calibri"/>
                         </a:rPr>
-                        <a:t>6</a:t>
+                        <a:t>3</a:t>
                       </a:r>
                     </a:p>
                   </a:txBody>
@@ -22249,7 +22249,7 @@
                           </a:solidFill>
                           <a:latin typeface="Calibri"/>
                         </a:rPr>
-                        <a:t>0.044</a:t>
+                        <a:t>0.045</a:t>
                       </a:r>
                     </a:p>
                   </a:txBody>
@@ -22295,7 +22295,7 @@
                           </a:solidFill>
                           <a:latin typeface="Calibri"/>
                         </a:rPr>
-                        <a:t>4</a:t>
+                        <a:t>5</a:t>
                       </a:r>
                     </a:p>
                   </a:txBody>
@@ -22412,7 +22412,7 @@
                           </a:solidFill>
                           <a:latin typeface="Calibri"/>
                         </a:rPr>
-                        <a:t>0.026</a:t>
+                        <a:t>0.025</a:t>
                       </a:r>
                     </a:p>
                   </a:txBody>
@@ -22458,7 +22458,7 @@
                           </a:solidFill>
                           <a:latin typeface="Calibri"/>
                         </a:rPr>
-                        <a:t>1</a:t>
+                        <a:t>4</a:t>
                       </a:r>
                     </a:p>
                   </a:txBody>
@@ -22621,7 +22621,7 @@
                           </a:solidFill>
                           <a:latin typeface="Calibri"/>
                         </a:rPr>
-                        <a:t>9</a:t>
+                        <a:t>8</a:t>
                       </a:r>
                     </a:p>
                   </a:txBody>
@@ -22738,7 +22738,7 @@
                           </a:solidFill>
                           <a:latin typeface="Calibri"/>
                         </a:rPr>
-                        <a:t>0.019</a:t>
+                        <a:t>0.017</a:t>
                       </a:r>
                     </a:p>
                   </a:txBody>
@@ -22784,7 +22784,7 @@
                           </a:solidFill>
                           <a:latin typeface="Calibri"/>
                         </a:rPr>
-                        <a:t>2</a:t>
+                        <a:t>10</a:t>
                       </a:r>
                     </a:p>
                   </a:txBody>
@@ -22901,7 +22901,7 @@
                           </a:solidFill>
                           <a:latin typeface="Calibri"/>
                         </a:rPr>
-                        <a:t>0.064</a:t>
+                        <a:t>0.065</a:t>
                       </a:r>
                     </a:p>
                   </a:txBody>
@@ -22947,7 +22947,7 @@
                           </a:solidFill>
                           <a:latin typeface="Calibri"/>
                         </a:rPr>
-                        <a:t>2</a:t>
+                        <a:t>7</a:t>
                       </a:r>
                     </a:p>
                   </a:txBody>
@@ -23039,7 +23039,7 @@
                 </a:solidFill>
                 <a:latin typeface="Calibri"/>
               </a:rPr>
-              <a:t>IICT · 0.096 · degree 380</a:t>
+              <a:t>IICT · 0.098 · degree 380</a:t>
             </a:r>
           </a:p>
           <a:p>
@@ -23064,7 +23064,7 @@
                 </a:solidFill>
                 <a:latin typeface="Calibri"/>
               </a:rPr>
-              <a:t>IICT · 0.090 · degree 285</a:t>
+              <a:t>IICT · 0.097 · degree 285</a:t>
             </a:r>
           </a:p>
           <a:p>
@@ -23089,7 +23089,7 @@
                 </a:solidFill>
                 <a:latin typeface="Calibri"/>
               </a:rPr>
-              <a:t>CECRI · 0.072 · degree 137</a:t>
+              <a:t>CECRI · 0.068 · degree 137</a:t>
             </a:r>
           </a:p>
           <a:p>
@@ -23114,7 +23114,7 @@
                 </a:solidFill>
                 <a:latin typeface="Calibri"/>
               </a:rPr>
-              <a:t>IICT · 0.064 · degree 150</a:t>
+              <a:t>IICT · 0.065 · degree 150</a:t>
             </a:r>
           </a:p>
           <a:p>

</xml_diff>